<commit_message>
Review 2 reading guide; fix VCO schematic wiring and diagram labels
- docs/review2_guide: 10-page cheatsheet (story, per-block explanation,
  results with figures, slide talking points, numbers, examiner Q&A)
- vco_schematic: Mn_cs gate was drawn tied to bias-gen VSS; netlist has
  vbiasn = vctrl. Redrawn to match, titles/labels no longer overlap
- pll_block_diagram: labels moved off wires; deck slide 5 now uses it

Co-Authored-By: Claude Opus 5.5 <noreply@anthropic.com>
</commit_message>
<xml_diff>
--- a/Design_of_a_Frequency_Synthesiser_Review-2.pptx
+++ b/Design_of_a_Frequency_Synthesiser_Review-2.pptx
@@ -12685,8 +12685,8 @@
         </p:blipFill>
         <p:spPr>
           <a:xfrm>
-            <a:off x="916078" y="1325880"/>
-            <a:ext cx="4448004" cy="3500000"/>
+            <a:off x="1005297" y="1325880"/>
+            <a:ext cx="4269565" cy="3500000"/>
           </a:xfrm>
           <a:prstGeom prst="rect">
             <a:avLst/>
@@ -19402,30 +19402,6 @@
           </a:prstGeom>
         </p:spPr>
       </p:pic>
-      <p:pic>
-        <p:nvPicPr>
-          <p:cNvPr id="5" name="Picture 4" descr="pll_block_diagram.png"/>
-          <p:cNvPicPr>
-            <a:picLocks noChangeAspect="1"/>
-          </p:cNvPicPr>
-          <p:nvPr/>
-        </p:nvPicPr>
-        <p:blipFill>
-          <a:blip r:embed="rId4"/>
-          <a:stretch>
-            <a:fillRect/>
-          </a:stretch>
-        </p:blipFill>
-        <p:spPr>
-          <a:xfrm>
-            <a:off x="640080" y="1327533"/>
-            <a:ext cx="10881360" cy="3196694"/>
-          </a:xfrm>
-          <a:prstGeom prst="rect">
-            <a:avLst/>
-          </a:prstGeom>
-        </p:spPr>
-      </p:pic>
       <p:sp>
         <p:nvSpPr>
           <p:cNvPr id="6" name="TextBox 5"/>
@@ -19500,6 +19476,30 @@
           </a:p>
         </p:txBody>
       </p:sp>
+      <p:pic>
+        <p:nvPicPr>
+          <p:cNvPr id="7" name="Picture 6" descr="pll_block_diagram.png"/>
+          <p:cNvPicPr>
+            <a:picLocks noChangeAspect="1"/>
+          </p:cNvPicPr>
+          <p:nvPr/>
+        </p:nvPicPr>
+        <p:blipFill>
+          <a:blip r:embed="rId5"/>
+          <a:stretch>
+            <a:fillRect/>
+          </a:stretch>
+        </p:blipFill>
+        <p:spPr>
+          <a:xfrm>
+            <a:off x="1390918" y="1327533"/>
+            <a:ext cx="9379683" cy="3196694"/>
+          </a:xfrm>
+          <a:prstGeom prst="rect">
+            <a:avLst/>
+          </a:prstGeom>
+        </p:spPr>
+      </p:pic>
     </p:spTree>
   </p:cSld>
   <p:clrMapOvr>

</xml_diff>